<commit_message>
update topic 7 - recursion
</commit_message>
<xml_diff>
--- a/topic07-recursive-functions/unit-07a-lectures/talk-1/a-recursion.pptx
+++ b/topic07-recursive-functions/unit-07a-lectures/talk-1/a-recursion.pptx
@@ -557,14 +557,14 @@
           </a:ln>
           <a:extLst>
             <a:ext uri="{909E8E84-426E-40dd-AFC4-6F175D3DCCD1}">
-              <a14:hiddenFill xmlns:a14="http://schemas.microsoft.com/office/drawing/2010/main" xmlns="">
+              <a14:hiddenFill xmlns="" xmlns:a14="http://schemas.microsoft.com/office/drawing/2010/main">
                 <a:solidFill>
                   <a:srgbClr val="FFFFFF"/>
                 </a:solidFill>
               </a14:hiddenFill>
             </a:ext>
             <a:ext uri="{FAA26D3D-D897-4be2-8F04-BA451C77F1D7}">
-              <ma14:placeholderFlag xmlns:ma14="http://schemas.microsoft.com/office/mac/drawingml/2011/main" xmlns="" val="1"/>
+              <ma14:placeholderFlag xmlns="" xmlns:ma14="http://schemas.microsoft.com/office/mac/drawingml/2011/main" val="1"/>
             </a:ext>
           </a:extLst>
         </p:spPr>
@@ -1142,7 +1142,7 @@
             <a:fld id="{08B9EBBA-996F-894A-B54A-D6246ED52CEA}" type="datetimeFigureOut">
               <a:rPr lang="en-US" smtClean="0"/>
               <a:pPr/>
-              <a:t>3/17/25</a:t>
+              <a:t>2/27/26</a:t>
             </a:fld>
             <a:endParaRPr lang="en-US" dirty="0"/>
           </a:p>
@@ -1564,7 +1564,7 @@
             <a:fld id="{09B482E8-6E0E-1B4F-B1FD-C69DB9E858D9}" type="datetimeFigureOut">
               <a:rPr lang="en-US" smtClean="0"/>
               <a:pPr/>
-              <a:t>3/17/25</a:t>
+              <a:t>2/27/26</a:t>
             </a:fld>
             <a:endParaRPr lang="en-US" dirty="0"/>
           </a:p>
@@ -1908,7 +1908,7 @@
             <a:fld id="{09B482E8-6E0E-1B4F-B1FD-C69DB9E858D9}" type="datetimeFigureOut">
               <a:rPr lang="en-US" smtClean="0"/>
               <a:pPr/>
-              <a:t>3/17/25</a:t>
+              <a:t>2/27/26</a:t>
             </a:fld>
             <a:endParaRPr lang="en-US" dirty="0"/>
           </a:p>
@@ -2321,7 +2321,7 @@
             <a:fld id="{09B482E8-6E0E-1B4F-B1FD-C69DB9E858D9}" type="datetimeFigureOut">
               <a:rPr lang="en-US" smtClean="0"/>
               <a:pPr/>
-              <a:t>3/17/25</a:t>
+              <a:t>2/27/26</a:t>
             </a:fld>
             <a:endParaRPr lang="en-US" dirty="0"/>
           </a:p>
@@ -2897,7 +2897,7 @@
             <a:fld id="{09B482E8-6E0E-1B4F-B1FD-C69DB9E858D9}" type="datetimeFigureOut">
               <a:rPr lang="en-US" smtClean="0"/>
               <a:pPr/>
-              <a:t>3/17/25</a:t>
+              <a:t>2/27/26</a:t>
             </a:fld>
             <a:endParaRPr lang="en-US" dirty="0"/>
           </a:p>
@@ -3586,7 +3586,7 @@
             <a:fld id="{09B482E8-6E0E-1B4F-B1FD-C69DB9E858D9}" type="datetimeFigureOut">
               <a:rPr lang="en-US" smtClean="0"/>
               <a:pPr/>
-              <a:t>3/17/25</a:t>
+              <a:t>2/27/26</a:t>
             </a:fld>
             <a:endParaRPr lang="en-US" dirty="0"/>
           </a:p>
@@ -4507,7 +4507,7 @@
             <a:fld id="{09B482E8-6E0E-1B4F-B1FD-C69DB9E858D9}" type="datetimeFigureOut">
               <a:rPr lang="en-US" smtClean="0"/>
               <a:pPr/>
-              <a:t>3/17/25</a:t>
+              <a:t>2/27/26</a:t>
             </a:fld>
             <a:endParaRPr lang="en-US" dirty="0"/>
           </a:p>
@@ -4828,7 +4828,7 @@
             <a:fld id="{09B482E8-6E0E-1B4F-B1FD-C69DB9E858D9}" type="datetimeFigureOut">
               <a:rPr lang="en-US" smtClean="0"/>
               <a:pPr/>
-              <a:t>3/17/25</a:t>
+              <a:t>2/27/26</a:t>
             </a:fld>
             <a:endParaRPr lang="en-US" dirty="0"/>
           </a:p>
@@ -5099,7 +5099,7 @@
             <a:fld id="{09B482E8-6E0E-1B4F-B1FD-C69DB9E858D9}" type="datetimeFigureOut">
               <a:rPr lang="en-US" smtClean="0"/>
               <a:pPr/>
-              <a:t>3/17/25</a:t>
+              <a:t>2/27/26</a:t>
             </a:fld>
             <a:endParaRPr lang="en-US" dirty="0"/>
           </a:p>
@@ -5429,7 +5429,7 @@
             <a:fld id="{09B482E8-6E0E-1B4F-B1FD-C69DB9E858D9}" type="datetimeFigureOut">
               <a:rPr lang="en-US" smtClean="0"/>
               <a:pPr/>
-              <a:t>3/17/25</a:t>
+              <a:t>2/27/26</a:t>
             </a:fld>
             <a:endParaRPr lang="en-US" dirty="0"/>
           </a:p>
@@ -5825,7 +5825,7 @@
             <a:fld id="{8DFA1846-DA80-1C48-A609-854EA85C59AD}" type="datetimeFigureOut">
               <a:rPr lang="en-US" smtClean="0"/>
               <a:pPr/>
-              <a:t>3/17/25</a:t>
+              <a:t>2/27/26</a:t>
             </a:fld>
             <a:endParaRPr lang="en-US" dirty="0"/>
           </a:p>
@@ -6208,7 +6208,7 @@
             <a:fld id="{09B482E8-6E0E-1B4F-B1FD-C69DB9E858D9}" type="datetimeFigureOut">
               <a:rPr lang="en-US" smtClean="0"/>
               <a:pPr/>
-              <a:t>3/17/25</a:t>
+              <a:t>2/27/26</a:t>
             </a:fld>
             <a:endParaRPr lang="en-US" dirty="0"/>
           </a:p>
@@ -6721,7 +6721,7 @@
             <a:fld id="{09B482E8-6E0E-1B4F-B1FD-C69DB9E858D9}" type="datetimeFigureOut">
               <a:rPr lang="en-US" smtClean="0"/>
               <a:pPr/>
-              <a:t>3/17/25</a:t>
+              <a:t>2/27/26</a:t>
             </a:fld>
             <a:endParaRPr lang="en-US" dirty="0"/>
           </a:p>
@@ -6985,7 +6985,7 @@
             <a:fld id="{F13A34C8-038E-2045-AF43-DF7DBB8E0E9E}" type="datetimeFigureOut">
               <a:rPr lang="en-US" smtClean="0"/>
               <a:pPr/>
-              <a:t>3/17/25</a:t>
+              <a:t>2/27/26</a:t>
             </a:fld>
             <a:endParaRPr lang="en-US" dirty="0"/>
           </a:p>
@@ -7136,6 +7136,13 @@
             <a:schemeClr val="lt1"/>
           </a:fontRef>
         </p:style>
+        <p:txBody>
+          <a:bodyPr/>
+          <a:lstStyle/>
+          <a:p>
+            <a:endParaRPr lang="en-US"/>
+          </a:p>
+        </p:txBody>
       </p:sp>
       <p:sp>
         <p:nvSpPr>
@@ -7155,7 +7162,7 @@
             <a:fld id="{8818C68F-D26B-8F47-958C-23B49CF8A634}" type="datetimeFigureOut">
               <a:rPr lang="en-US" smtClean="0"/>
               <a:pPr/>
-              <a:t>3/17/25</a:t>
+              <a:t>2/27/26</a:t>
             </a:fld>
             <a:endParaRPr lang="en-US" dirty="0"/>
           </a:p>
@@ -7552,7 +7559,7 @@
             <a:fld id="{09B482E8-6E0E-1B4F-B1FD-C69DB9E858D9}" type="datetimeFigureOut">
               <a:rPr lang="en-US" smtClean="0"/>
               <a:pPr/>
-              <a:t>3/17/25</a:t>
+              <a:t>2/27/26</a:t>
             </a:fld>
             <a:endParaRPr lang="en-US" dirty="0"/>
           </a:p>
@@ -7968,7 +7975,7 @@
             <a:fld id="{09B482E8-6E0E-1B4F-B1FD-C69DB9E858D9}" type="datetimeFigureOut">
               <a:rPr lang="en-US" smtClean="0"/>
               <a:pPr/>
-              <a:t>3/17/25</a:t>
+              <a:t>2/27/26</a:t>
             </a:fld>
             <a:endParaRPr lang="en-US" dirty="0"/>
           </a:p>
@@ -8219,7 +8226,7 @@
             <a:fld id="{09B482E8-6E0E-1B4F-B1FD-C69DB9E858D9}" type="datetimeFigureOut">
               <a:rPr lang="en-US" smtClean="0"/>
               <a:pPr/>
-              <a:t>3/17/25</a:t>
+              <a:t>2/27/26</a:t>
             </a:fld>
             <a:endParaRPr lang="en-US" dirty="0"/>
           </a:p>
@@ -8656,14 +8663,14 @@
           <a:noFill/>
           <a:extLst>
             <a:ext uri="{909E8E84-426E-40dd-AFC4-6F175D3DCCD1}">
-              <a14:hiddenFill xmlns:a14="http://schemas.microsoft.com/office/drawing/2010/main" xmlns="">
+              <a14:hiddenFill xmlns="" xmlns:a14="http://schemas.microsoft.com/office/drawing/2010/main">
                 <a:solidFill>
                   <a:srgbClr val="FFFFFF"/>
                 </a:solidFill>
               </a14:hiddenFill>
             </a:ext>
             <a:ext uri="{91240B29-F687-4f45-9708-019B960494DF}">
-              <a14:hiddenLine xmlns:a14="http://schemas.microsoft.com/office/drawing/2010/main" xmlns="" w="9525">
+              <a14:hiddenLine xmlns="" xmlns:a14="http://schemas.microsoft.com/office/drawing/2010/main" w="9525">
                 <a:solidFill>
                   <a:srgbClr val="000000"/>
                 </a:solidFill>
@@ -8871,7 +8878,7 @@
               <a:rPr kumimoji="1" lang="en-US" sz="3200" dirty="0">
                 <a:cs typeface="+mn-cs"/>
               </a:rPr>
-              <a:t>Chapter 7.1 – Recursive Functions</a:t>
+              <a:t>Topic 7.1 – Recursive Functions</a:t>
             </a:r>
           </a:p>
         </p:txBody>
@@ -8911,14 +8918,14 @@
           </a:ln>
           <a:extLst>
             <a:ext uri="{909E8E84-426E-40dd-AFC4-6F175D3DCCD1}">
-              <a14:hiddenFill xmlns:a14="http://schemas.microsoft.com/office/drawing/2010/main" xmlns="">
+              <a14:hiddenFill xmlns="" xmlns:a14="http://schemas.microsoft.com/office/drawing/2010/main">
                 <a:solidFill>
                   <a:srgbClr val="FFFFFF"/>
                 </a:solidFill>
               </a14:hiddenFill>
             </a:ext>
             <a:ext uri="{91240B29-F687-4f45-9708-019B960494DF}">
-              <a14:hiddenLine xmlns:a14="http://schemas.microsoft.com/office/drawing/2010/main" xmlns="" w="9525">
+              <a14:hiddenLine xmlns="" xmlns:a14="http://schemas.microsoft.com/office/drawing/2010/main" w="9525">
                 <a:solidFill>
                   <a:srgbClr val="000000"/>
                 </a:solidFill>
@@ -8997,14 +9004,14 @@
           <a:noFill/>
           <a:extLst>
             <a:ext uri="{909E8E84-426E-40dd-AFC4-6F175D3DCCD1}">
-              <a14:hiddenFill xmlns:a14="http://schemas.microsoft.com/office/drawing/2010/main" xmlns="">
+              <a14:hiddenFill xmlns="" xmlns:a14="http://schemas.microsoft.com/office/drawing/2010/main">
                 <a:solidFill>
                   <a:srgbClr val="FFFFFF"/>
                 </a:solidFill>
               </a14:hiddenFill>
             </a:ext>
             <a:ext uri="{91240B29-F687-4f45-9708-019B960494DF}">
-              <a14:hiddenLine xmlns:a14="http://schemas.microsoft.com/office/drawing/2010/main" xmlns="" w="9525">
+              <a14:hiddenLine xmlns="" xmlns:a14="http://schemas.microsoft.com/office/drawing/2010/main" w="9525">
                 <a:solidFill>
                   <a:srgbClr val="000000"/>
                 </a:solidFill>
@@ -10039,14 +10046,14 @@
           <a:noFill/>
           <a:extLst>
             <a:ext uri="{909E8E84-426E-40dd-AFC4-6F175D3DCCD1}">
-              <a14:hiddenFill xmlns:a14="http://schemas.microsoft.com/office/drawing/2010/main" xmlns="">
+              <a14:hiddenFill xmlns="" xmlns:a14="http://schemas.microsoft.com/office/drawing/2010/main">
                 <a:solidFill>
                   <a:srgbClr val="FFFFFF"/>
                 </a:solidFill>
               </a14:hiddenFill>
             </a:ext>
             <a:ext uri="{91240B29-F687-4f45-9708-019B960494DF}">
-              <a14:hiddenLine xmlns:a14="http://schemas.microsoft.com/office/drawing/2010/main" xmlns="" w="9525">
+              <a14:hiddenLine xmlns="" xmlns:a14="http://schemas.microsoft.com/office/drawing/2010/main" w="9525">
                 <a:solidFill>
                   <a:srgbClr val="000000"/>
                 </a:solidFill>
@@ -10359,14 +10366,14 @@
           </a:ln>
           <a:extLst>
             <a:ext uri="{909E8E84-426E-40dd-AFC4-6F175D3DCCD1}">
-              <a14:hiddenFill xmlns:a14="http://schemas.microsoft.com/office/drawing/2010/main" xmlns="">
+              <a14:hiddenFill xmlns="" xmlns:a14="http://schemas.microsoft.com/office/drawing/2010/main">
                 <a:solidFill>
                   <a:srgbClr val="FFFFFF"/>
                 </a:solidFill>
               </a14:hiddenFill>
             </a:ext>
             <a:ext uri="{91240B29-F687-4f45-9708-019B960494DF}">
-              <a14:hiddenLine xmlns:a14="http://schemas.microsoft.com/office/drawing/2010/main" xmlns="" w="9525">
+              <a14:hiddenLine xmlns="" xmlns:a14="http://schemas.microsoft.com/office/drawing/2010/main" w="9525">
                 <a:solidFill>
                   <a:srgbClr val="000000"/>
                 </a:solidFill>
@@ -10376,7 +10383,7 @@
               </a14:hiddenLine>
             </a:ext>
             <a:ext uri="{FAA26D3D-D897-4be2-8F04-BA451C77F1D7}">
-              <ma14:placeholderFlag xmlns:ma14="http://schemas.microsoft.com/office/mac/drawingml/2011/main" xmlns="" val="1"/>
+              <ma14:placeholderFlag xmlns="" xmlns:ma14="http://schemas.microsoft.com/office/mac/drawingml/2011/main" val="1"/>
             </a:ext>
           </a:extLst>
         </p:spPr>
@@ -10916,14 +10923,14 @@
           <a:noFill/>
           <a:extLst>
             <a:ext uri="{909E8E84-426E-40dd-AFC4-6F175D3DCCD1}">
-              <a14:hiddenFill xmlns:a14="http://schemas.microsoft.com/office/drawing/2010/main" xmlns="">
+              <a14:hiddenFill xmlns="" xmlns:a14="http://schemas.microsoft.com/office/drawing/2010/main">
                 <a:solidFill>
                   <a:srgbClr val="FFFFFF"/>
                 </a:solidFill>
               </a14:hiddenFill>
             </a:ext>
             <a:ext uri="{91240B29-F687-4f45-9708-019B960494DF}">
-              <a14:hiddenLine xmlns:a14="http://schemas.microsoft.com/office/drawing/2010/main" xmlns="" w="9525">
+              <a14:hiddenLine xmlns="" xmlns:a14="http://schemas.microsoft.com/office/drawing/2010/main" w="9525">
                 <a:solidFill>
                   <a:srgbClr val="000000"/>
                 </a:solidFill>
@@ -12329,14 +12336,14 @@
           <a:noFill/>
           <a:extLst>
             <a:ext uri="{909E8E84-426E-40dd-AFC4-6F175D3DCCD1}">
-              <a14:hiddenFill xmlns:a14="http://schemas.microsoft.com/office/drawing/2010/main" xmlns="">
+              <a14:hiddenFill xmlns="" xmlns:a14="http://schemas.microsoft.com/office/drawing/2010/main">
                 <a:solidFill>
                   <a:srgbClr val="FFFFFF"/>
                 </a:solidFill>
               </a14:hiddenFill>
             </a:ext>
             <a:ext uri="{91240B29-F687-4f45-9708-019B960494DF}">
-              <a14:hiddenLine xmlns:a14="http://schemas.microsoft.com/office/drawing/2010/main" xmlns="" w="9525">
+              <a14:hiddenLine xmlns="" xmlns:a14="http://schemas.microsoft.com/office/drawing/2010/main" w="9525">
                 <a:solidFill>
                   <a:srgbClr val="000000"/>
                 </a:solidFill>
@@ -12517,8 +12524,8 @@
         </p:nvSpPr>
         <p:spPr bwMode="auto">
           <a:xfrm>
-            <a:off x="1264083" y="2297256"/>
-            <a:ext cx="8178800" cy="1923616"/>
+            <a:off x="680321" y="2435235"/>
+            <a:ext cx="10358580" cy="2588600"/>
           </a:xfrm>
           <a:prstGeom prst="rect">
             <a:avLst/>
@@ -12529,14 +12536,14 @@
           </a:ln>
           <a:extLst>
             <a:ext uri="{909E8E84-426E-40dd-AFC4-6F175D3DCCD1}">
-              <a14:hiddenFill xmlns:a14="http://schemas.microsoft.com/office/drawing/2010/main" xmlns="">
+              <a14:hiddenFill xmlns="" xmlns:a14="http://schemas.microsoft.com/office/drawing/2010/main">
                 <a:solidFill>
                   <a:srgbClr val="FFFFFF"/>
                 </a:solidFill>
               </a14:hiddenFill>
             </a:ext>
             <a:ext uri="{91240B29-F687-4f45-9708-019B960494DF}">
-              <a14:hiddenLine xmlns:a14="http://schemas.microsoft.com/office/drawing/2010/main" xmlns="" w="9525">
+              <a14:hiddenLine xmlns="" xmlns:a14="http://schemas.microsoft.com/office/drawing/2010/main" w="9525">
                 <a:solidFill>
                   <a:srgbClr val="000000"/>
                 </a:solidFill>
@@ -12727,6 +12734,336 @@
   <p:clrMapOvr>
     <a:masterClrMapping/>
   </p:clrMapOvr>
+  <p:timing>
+    <p:tnLst>
+      <p:par>
+        <p:cTn id="1" dur="indefinite" restart="never" nodeType="tmRoot">
+          <p:childTnLst>
+            <p:seq concurrent="1" nextAc="seek">
+              <p:cTn id="2" dur="indefinite" nodeType="mainSeq">
+                <p:childTnLst>
+                  <p:par>
+                    <p:cTn id="3" fill="hold">
+                      <p:stCondLst>
+                        <p:cond delay="indefinite"/>
+                      </p:stCondLst>
+                      <p:childTnLst>
+                        <p:par>
+                          <p:cTn id="4" fill="hold">
+                            <p:stCondLst>
+                              <p:cond delay="0"/>
+                            </p:stCondLst>
+                            <p:childTnLst>
+                              <p:par>
+                                <p:cTn id="5" presetID="2" presetClass="entr" presetSubtype="4" fill="hold" nodeType="clickEffect">
+                                  <p:stCondLst>
+                                    <p:cond delay="0"/>
+                                  </p:stCondLst>
+                                  <p:childTnLst>
+                                    <p:set>
+                                      <p:cBhvr>
+                                        <p:cTn id="6" dur="1" fill="hold">
+                                          <p:stCondLst>
+                                            <p:cond delay="0"/>
+                                          </p:stCondLst>
+                                        </p:cTn>
+                                        <p:tgtEl>
+                                          <p:spTgt spid="20483">
+                                            <p:txEl>
+                                              <p:pRg st="0" end="0"/>
+                                            </p:txEl>
+                                          </p:spTgt>
+                                        </p:tgtEl>
+                                        <p:attrNameLst>
+                                          <p:attrName>style.visibility</p:attrName>
+                                        </p:attrNameLst>
+                                      </p:cBhvr>
+                                      <p:to>
+                                        <p:strVal val="visible"/>
+                                      </p:to>
+                                    </p:set>
+                                    <p:anim calcmode="lin" valueType="num">
+                                      <p:cBhvr additive="base">
+                                        <p:cTn id="7" dur="500" fill="hold"/>
+                                        <p:tgtEl>
+                                          <p:spTgt spid="20483">
+                                            <p:txEl>
+                                              <p:pRg st="0" end="0"/>
+                                            </p:txEl>
+                                          </p:spTgt>
+                                        </p:tgtEl>
+                                        <p:attrNameLst>
+                                          <p:attrName>ppt_x</p:attrName>
+                                        </p:attrNameLst>
+                                      </p:cBhvr>
+                                      <p:tavLst>
+                                        <p:tav tm="0">
+                                          <p:val>
+                                            <p:strVal val="#ppt_x"/>
+                                          </p:val>
+                                        </p:tav>
+                                        <p:tav tm="100000">
+                                          <p:val>
+                                            <p:strVal val="#ppt_x"/>
+                                          </p:val>
+                                        </p:tav>
+                                      </p:tavLst>
+                                    </p:anim>
+                                    <p:anim calcmode="lin" valueType="num">
+                                      <p:cBhvr additive="base">
+                                        <p:cTn id="8" dur="500" fill="hold"/>
+                                        <p:tgtEl>
+                                          <p:spTgt spid="20483">
+                                            <p:txEl>
+                                              <p:pRg st="0" end="0"/>
+                                            </p:txEl>
+                                          </p:spTgt>
+                                        </p:tgtEl>
+                                        <p:attrNameLst>
+                                          <p:attrName>ppt_y</p:attrName>
+                                        </p:attrNameLst>
+                                      </p:cBhvr>
+                                      <p:tavLst>
+                                        <p:tav tm="0">
+                                          <p:val>
+                                            <p:strVal val="1+#ppt_h/2"/>
+                                          </p:val>
+                                        </p:tav>
+                                        <p:tav tm="100000">
+                                          <p:val>
+                                            <p:strVal val="#ppt_y"/>
+                                          </p:val>
+                                        </p:tav>
+                                      </p:tavLst>
+                                    </p:anim>
+                                  </p:childTnLst>
+                                </p:cTn>
+                              </p:par>
+                            </p:childTnLst>
+                          </p:cTn>
+                        </p:par>
+                      </p:childTnLst>
+                    </p:cTn>
+                  </p:par>
+                  <p:par>
+                    <p:cTn id="9" fill="hold">
+                      <p:stCondLst>
+                        <p:cond delay="indefinite"/>
+                      </p:stCondLst>
+                      <p:childTnLst>
+                        <p:par>
+                          <p:cTn id="10" fill="hold">
+                            <p:stCondLst>
+                              <p:cond delay="0"/>
+                            </p:stCondLst>
+                            <p:childTnLst>
+                              <p:par>
+                                <p:cTn id="11" presetID="2" presetClass="entr" presetSubtype="4" fill="hold" nodeType="clickEffect">
+                                  <p:stCondLst>
+                                    <p:cond delay="0"/>
+                                  </p:stCondLst>
+                                  <p:childTnLst>
+                                    <p:set>
+                                      <p:cBhvr>
+                                        <p:cTn id="12" dur="1" fill="hold">
+                                          <p:stCondLst>
+                                            <p:cond delay="0"/>
+                                          </p:stCondLst>
+                                        </p:cTn>
+                                        <p:tgtEl>
+                                          <p:spTgt spid="20483">
+                                            <p:txEl>
+                                              <p:pRg st="2" end="2"/>
+                                            </p:txEl>
+                                          </p:spTgt>
+                                        </p:tgtEl>
+                                        <p:attrNameLst>
+                                          <p:attrName>style.visibility</p:attrName>
+                                        </p:attrNameLst>
+                                      </p:cBhvr>
+                                      <p:to>
+                                        <p:strVal val="visible"/>
+                                      </p:to>
+                                    </p:set>
+                                    <p:anim calcmode="lin" valueType="num">
+                                      <p:cBhvr additive="base">
+                                        <p:cTn id="13" dur="500" fill="hold"/>
+                                        <p:tgtEl>
+                                          <p:spTgt spid="20483">
+                                            <p:txEl>
+                                              <p:pRg st="2" end="2"/>
+                                            </p:txEl>
+                                          </p:spTgt>
+                                        </p:tgtEl>
+                                        <p:attrNameLst>
+                                          <p:attrName>ppt_x</p:attrName>
+                                        </p:attrNameLst>
+                                      </p:cBhvr>
+                                      <p:tavLst>
+                                        <p:tav tm="0">
+                                          <p:val>
+                                            <p:strVal val="#ppt_x"/>
+                                          </p:val>
+                                        </p:tav>
+                                        <p:tav tm="100000">
+                                          <p:val>
+                                            <p:strVal val="#ppt_x"/>
+                                          </p:val>
+                                        </p:tav>
+                                      </p:tavLst>
+                                    </p:anim>
+                                    <p:anim calcmode="lin" valueType="num">
+                                      <p:cBhvr additive="base">
+                                        <p:cTn id="14" dur="500" fill="hold"/>
+                                        <p:tgtEl>
+                                          <p:spTgt spid="20483">
+                                            <p:txEl>
+                                              <p:pRg st="2" end="2"/>
+                                            </p:txEl>
+                                          </p:spTgt>
+                                        </p:tgtEl>
+                                        <p:attrNameLst>
+                                          <p:attrName>ppt_y</p:attrName>
+                                        </p:attrNameLst>
+                                      </p:cBhvr>
+                                      <p:tavLst>
+                                        <p:tav tm="0">
+                                          <p:val>
+                                            <p:strVal val="1+#ppt_h/2"/>
+                                          </p:val>
+                                        </p:tav>
+                                        <p:tav tm="100000">
+                                          <p:val>
+                                            <p:strVal val="#ppt_y"/>
+                                          </p:val>
+                                        </p:tav>
+                                      </p:tavLst>
+                                    </p:anim>
+                                  </p:childTnLst>
+                                </p:cTn>
+                              </p:par>
+                            </p:childTnLst>
+                          </p:cTn>
+                        </p:par>
+                      </p:childTnLst>
+                    </p:cTn>
+                  </p:par>
+                  <p:par>
+                    <p:cTn id="15" fill="hold">
+                      <p:stCondLst>
+                        <p:cond delay="indefinite"/>
+                      </p:stCondLst>
+                      <p:childTnLst>
+                        <p:par>
+                          <p:cTn id="16" fill="hold">
+                            <p:stCondLst>
+                              <p:cond delay="0"/>
+                            </p:stCondLst>
+                            <p:childTnLst>
+                              <p:par>
+                                <p:cTn id="17" presetID="2" presetClass="entr" presetSubtype="4" fill="hold" grpId="0" nodeType="clickEffect">
+                                  <p:stCondLst>
+                                    <p:cond delay="0"/>
+                                  </p:stCondLst>
+                                  <p:childTnLst>
+                                    <p:set>
+                                      <p:cBhvr>
+                                        <p:cTn id="18" dur="1" fill="hold">
+                                          <p:stCondLst>
+                                            <p:cond delay="0"/>
+                                          </p:stCondLst>
+                                        </p:cTn>
+                                        <p:tgtEl>
+                                          <p:spTgt spid="293893"/>
+                                        </p:tgtEl>
+                                        <p:attrNameLst>
+                                          <p:attrName>style.visibility</p:attrName>
+                                        </p:attrNameLst>
+                                      </p:cBhvr>
+                                      <p:to>
+                                        <p:strVal val="visible"/>
+                                      </p:to>
+                                    </p:set>
+                                    <p:anim calcmode="lin" valueType="num">
+                                      <p:cBhvr additive="base">
+                                        <p:cTn id="19" dur="500" fill="hold"/>
+                                        <p:tgtEl>
+                                          <p:spTgt spid="293893"/>
+                                        </p:tgtEl>
+                                        <p:attrNameLst>
+                                          <p:attrName>ppt_x</p:attrName>
+                                        </p:attrNameLst>
+                                      </p:cBhvr>
+                                      <p:tavLst>
+                                        <p:tav tm="0">
+                                          <p:val>
+                                            <p:strVal val="#ppt_x"/>
+                                          </p:val>
+                                        </p:tav>
+                                        <p:tav tm="100000">
+                                          <p:val>
+                                            <p:strVal val="#ppt_x"/>
+                                          </p:val>
+                                        </p:tav>
+                                      </p:tavLst>
+                                    </p:anim>
+                                    <p:anim calcmode="lin" valueType="num">
+                                      <p:cBhvr additive="base">
+                                        <p:cTn id="20" dur="500" fill="hold"/>
+                                        <p:tgtEl>
+                                          <p:spTgt spid="293893"/>
+                                        </p:tgtEl>
+                                        <p:attrNameLst>
+                                          <p:attrName>ppt_y</p:attrName>
+                                        </p:attrNameLst>
+                                      </p:cBhvr>
+                                      <p:tavLst>
+                                        <p:tav tm="0">
+                                          <p:val>
+                                            <p:strVal val="1+#ppt_h/2"/>
+                                          </p:val>
+                                        </p:tav>
+                                        <p:tav tm="100000">
+                                          <p:val>
+                                            <p:strVal val="#ppt_y"/>
+                                          </p:val>
+                                        </p:tav>
+                                      </p:tavLst>
+                                    </p:anim>
+                                  </p:childTnLst>
+                                </p:cTn>
+                              </p:par>
+                            </p:childTnLst>
+                          </p:cTn>
+                        </p:par>
+                      </p:childTnLst>
+                    </p:cTn>
+                  </p:par>
+                </p:childTnLst>
+              </p:cTn>
+              <p:prevCondLst>
+                <p:cond evt="onPrev" delay="0">
+                  <p:tgtEl>
+                    <p:sldTgt/>
+                  </p:tgtEl>
+                </p:cond>
+              </p:prevCondLst>
+              <p:nextCondLst>
+                <p:cond evt="onNext" delay="0">
+                  <p:tgtEl>
+                    <p:sldTgt/>
+                  </p:tgtEl>
+                </p:cond>
+              </p:nextCondLst>
+            </p:seq>
+          </p:childTnLst>
+        </p:cTn>
+      </p:par>
+    </p:tnLst>
+    <p:bldLst>
+      <p:bldP spid="293893" grpId="0" animBg="1"/>
+    </p:bldLst>
+  </p:timing>
 </p:sld>
 </file>
 
@@ -12789,8 +13126,8 @@
         </p:nvSpPr>
         <p:spPr>
           <a:xfrm>
-            <a:off x="1389783" y="2344016"/>
-            <a:ext cx="8585489" cy="4153766"/>
+            <a:off x="727113" y="2344016"/>
+            <a:ext cx="10124501" cy="4153766"/>
           </a:xfrm>
         </p:spPr>
         <p:txBody>
@@ -12811,7 +13148,7 @@
                 <a:latin typeface="Tahoma" charset="0"/>
                 <a:ea typeface="ＭＳ Ｐゴシック" charset="0"/>
               </a:rPr>
-              <a:t>Some functions, such as factorial, are </a:t>
+              <a:t> Some functions, such as factorial, are </a:t>
             </a:r>
             <a:r>
               <a:rPr lang="en-US" sz="2800" u="sng" dirty="0">
@@ -12854,7 +13191,7 @@
                 <a:latin typeface="Tahoma" charset="0"/>
                 <a:ea typeface="ＭＳ Ｐゴシック" charset="0"/>
               </a:rPr>
-              <a:t>As we shall see, however, many functions can </a:t>
+              <a:t> As we shall see, however, many functions can </a:t>
             </a:r>
             <a:r>
               <a:rPr lang="en-US" sz="2800" u="sng" dirty="0">
@@ -12897,7 +13234,7 @@
                 <a:latin typeface="Tahoma" charset="0"/>
                 <a:ea typeface="ＭＳ Ｐゴシック" charset="0"/>
               </a:rPr>
-              <a:t>Properties of functions defined using recursion can be proved using the simple but powerful mathematical technique of </a:t>
+              <a:t> Properties of functions defined using recursion can be proved using the simple but powerful mathematical technique of </a:t>
             </a:r>
             <a:r>
               <a:rPr lang="en-US" sz="2800" u="sng" dirty="0">
@@ -12930,14 +13267,14 @@
           <a:noFill/>
           <a:extLst>
             <a:ext uri="{909E8E84-426E-40dd-AFC4-6F175D3DCCD1}">
-              <a14:hiddenFill xmlns:a14="http://schemas.microsoft.com/office/drawing/2010/main" xmlns="">
+              <a14:hiddenFill xmlns="" xmlns:a14="http://schemas.microsoft.com/office/drawing/2010/main">
                 <a:solidFill>
                   <a:srgbClr val="FFFFFF"/>
                 </a:solidFill>
               </a14:hiddenFill>
             </a:ext>
             <a:ext uri="{91240B29-F687-4f45-9708-019B960494DF}">
-              <a14:hiddenLine xmlns:a14="http://schemas.microsoft.com/office/drawing/2010/main" xmlns="" w="9525">
+              <a14:hiddenLine xmlns="" xmlns:a14="http://schemas.microsoft.com/office/drawing/2010/main" w="9525">
                 <a:solidFill>
                   <a:srgbClr val="000000"/>
                 </a:solidFill>
@@ -13473,14 +13810,14 @@
           <a:noFill/>
           <a:extLst>
             <a:ext uri="{909E8E84-426E-40dd-AFC4-6F175D3DCCD1}">
-              <a14:hiddenFill xmlns:a14="http://schemas.microsoft.com/office/drawing/2010/main" xmlns="">
+              <a14:hiddenFill xmlns="" xmlns:a14="http://schemas.microsoft.com/office/drawing/2010/main">
                 <a:solidFill>
                   <a:srgbClr val="FFFFFF"/>
                 </a:solidFill>
               </a14:hiddenFill>
             </a:ext>
             <a:ext uri="{91240B29-F687-4f45-9708-019B960494DF}">
-              <a14:hiddenLine xmlns:a14="http://schemas.microsoft.com/office/drawing/2010/main" xmlns="" w="9525">
+              <a14:hiddenLine xmlns="" xmlns:a14="http://schemas.microsoft.com/office/drawing/2010/main" w="9525">
                 <a:solidFill>
                   <a:srgbClr val="000000"/>
                 </a:solidFill>
@@ -14104,14 +14441,14 @@
           <a:noFill/>
           <a:extLst>
             <a:ext uri="{909E8E84-426E-40dd-AFC4-6F175D3DCCD1}">
-              <a14:hiddenFill xmlns:a14="http://schemas.microsoft.com/office/drawing/2010/main" xmlns="">
+              <a14:hiddenFill xmlns="" xmlns:a14="http://schemas.microsoft.com/office/drawing/2010/main">
                 <a:solidFill>
                   <a:srgbClr val="FFFFFF"/>
                 </a:solidFill>
               </a14:hiddenFill>
             </a:ext>
             <a:ext uri="{91240B29-F687-4f45-9708-019B960494DF}">
-              <a14:hiddenLine xmlns:a14="http://schemas.microsoft.com/office/drawing/2010/main" xmlns="" w="9525">
+              <a14:hiddenLine xmlns="" xmlns:a14="http://schemas.microsoft.com/office/drawing/2010/main" w="9525">
                 <a:solidFill>
                   <a:srgbClr val="000000"/>
                 </a:solidFill>
@@ -15205,14 +15542,14 @@
           <a:noFill/>
           <a:extLst>
             <a:ext uri="{909E8E84-426E-40dd-AFC4-6F175D3DCCD1}">
-              <a14:hiddenFill xmlns:a14="http://schemas.microsoft.com/office/drawing/2010/main" xmlns="">
+              <a14:hiddenFill xmlns="" xmlns:a14="http://schemas.microsoft.com/office/drawing/2010/main">
                 <a:solidFill>
                   <a:srgbClr val="FFFFFF"/>
                 </a:solidFill>
               </a14:hiddenFill>
             </a:ext>
             <a:ext uri="{91240B29-F687-4f45-9708-019B960494DF}">
-              <a14:hiddenLine xmlns:a14="http://schemas.microsoft.com/office/drawing/2010/main" xmlns="" w="9525">
+              <a14:hiddenLine xmlns="" xmlns:a14="http://schemas.microsoft.com/office/drawing/2010/main" w="9525">
                 <a:solidFill>
                   <a:srgbClr val="000000"/>
                 </a:solidFill>
@@ -15820,14 +16157,14 @@
           <a:noFill/>
           <a:extLst>
             <a:ext uri="{909E8E84-426E-40dd-AFC4-6F175D3DCCD1}">
-              <a14:hiddenFill xmlns:a14="http://schemas.microsoft.com/office/drawing/2010/main" xmlns="">
+              <a14:hiddenFill xmlns="" xmlns:a14="http://schemas.microsoft.com/office/drawing/2010/main">
                 <a:solidFill>
                   <a:srgbClr val="FFFFFF"/>
                 </a:solidFill>
               </a14:hiddenFill>
             </a:ext>
             <a:ext uri="{91240B29-F687-4f45-9708-019B960494DF}">
-              <a14:hiddenLine xmlns:a14="http://schemas.microsoft.com/office/drawing/2010/main" xmlns="" w="9525">
+              <a14:hiddenLine xmlns="" xmlns:a14="http://schemas.microsoft.com/office/drawing/2010/main" w="9525">
                 <a:solidFill>
                   <a:srgbClr val="000000"/>
                 </a:solidFill>
@@ -16921,14 +17258,14 @@
           <a:noFill/>
           <a:extLst>
             <a:ext uri="{909E8E84-426E-40dd-AFC4-6F175D3DCCD1}">
-              <a14:hiddenFill xmlns:a14="http://schemas.microsoft.com/office/drawing/2010/main" xmlns="">
+              <a14:hiddenFill xmlns="" xmlns:a14="http://schemas.microsoft.com/office/drawing/2010/main">
                 <a:solidFill>
                   <a:srgbClr val="FFFFFF"/>
                 </a:solidFill>
               </a14:hiddenFill>
             </a:ext>
             <a:ext uri="{91240B29-F687-4f45-9708-019B960494DF}">
-              <a14:hiddenLine xmlns:a14="http://schemas.microsoft.com/office/drawing/2010/main" xmlns="" w="9525">
+              <a14:hiddenLine xmlns="" xmlns:a14="http://schemas.microsoft.com/office/drawing/2010/main" w="9525">
                 <a:solidFill>
                   <a:srgbClr val="000000"/>
                 </a:solidFill>
@@ -17538,14 +17875,14 @@
           <a:noFill/>
           <a:extLst>
             <a:ext uri="{909E8E84-426E-40dd-AFC4-6F175D3DCCD1}">
-              <a14:hiddenFill xmlns:a14="http://schemas.microsoft.com/office/drawing/2010/main" xmlns="">
+              <a14:hiddenFill xmlns="" xmlns:a14="http://schemas.microsoft.com/office/drawing/2010/main">
                 <a:solidFill>
                   <a:srgbClr val="FFFFFF"/>
                 </a:solidFill>
               </a14:hiddenFill>
             </a:ext>
             <a:ext uri="{91240B29-F687-4f45-9708-019B960494DF}">
-              <a14:hiddenLine xmlns:a14="http://schemas.microsoft.com/office/drawing/2010/main" xmlns="" w="9525">
+              <a14:hiddenLine xmlns="" xmlns:a14="http://schemas.microsoft.com/office/drawing/2010/main" w="9525">
                 <a:solidFill>
                   <a:srgbClr val="000000"/>
                 </a:solidFill>
@@ -17808,14 +18145,14 @@
           <a:noFill/>
           <a:extLst>
             <a:ext uri="{909E8E84-426E-40dd-AFC4-6F175D3DCCD1}">
-              <a14:hiddenFill xmlns:a14="http://schemas.microsoft.com/office/drawing/2010/main" xmlns="">
+              <a14:hiddenFill xmlns="" xmlns:a14="http://schemas.microsoft.com/office/drawing/2010/main">
                 <a:solidFill>
                   <a:srgbClr val="FFFFFF"/>
                 </a:solidFill>
               </a14:hiddenFill>
             </a:ext>
             <a:ext uri="{91240B29-F687-4f45-9708-019B960494DF}">
-              <a14:hiddenLine xmlns:a14="http://schemas.microsoft.com/office/drawing/2010/main" xmlns="" w="9525">
+              <a14:hiddenLine xmlns="" xmlns:a14="http://schemas.microsoft.com/office/drawing/2010/main" w="9525">
                 <a:solidFill>
                   <a:srgbClr val="000000"/>
                 </a:solidFill>
@@ -18909,14 +19246,14 @@
           <a:noFill/>
           <a:extLst>
             <a:ext uri="{909E8E84-426E-40dd-AFC4-6F175D3DCCD1}">
-              <a14:hiddenFill xmlns:a14="http://schemas.microsoft.com/office/drawing/2010/main" xmlns="">
+              <a14:hiddenFill xmlns="" xmlns:a14="http://schemas.microsoft.com/office/drawing/2010/main">
                 <a:solidFill>
                   <a:srgbClr val="FFFFFF"/>
                 </a:solidFill>
               </a14:hiddenFill>
             </a:ext>
             <a:ext uri="{91240B29-F687-4f45-9708-019B960494DF}">
-              <a14:hiddenLine xmlns:a14="http://schemas.microsoft.com/office/drawing/2010/main" xmlns="" w="9525">
+              <a14:hiddenLine xmlns="" xmlns:a14="http://schemas.microsoft.com/office/drawing/2010/main" w="9525">
                 <a:solidFill>
                   <a:srgbClr val="000000"/>
                 </a:solidFill>
@@ -19184,8 +19521,8 @@
         </p:nvSpPr>
         <p:spPr>
           <a:xfrm>
-            <a:off x="3952373" y="2031399"/>
-            <a:ext cx="6599088" cy="1384995"/>
+            <a:off x="2835039" y="2042391"/>
+            <a:ext cx="6870821" cy="954107"/>
           </a:xfrm>
           <a:prstGeom prst="rect">
             <a:avLst/>
@@ -19240,14 +19577,14 @@
           <a:effectLst/>
           <a:extLst>
             <a:ext uri="{909E8E84-426E-40dd-AFC4-6F175D3DCCD1}">
-              <a14:hiddenFill xmlns:a14="http://schemas.microsoft.com/office/drawing/2010/main" xmlns="">
+              <a14:hiddenFill xmlns="" xmlns:a14="http://schemas.microsoft.com/office/drawing/2010/main">
                 <a:solidFill>
                   <a:schemeClr val="accent1"/>
                 </a:solidFill>
               </a14:hiddenFill>
             </a:ext>
             <a:ext uri="{AF507438-7753-43e0-B8FC-AC1667EBCBE1}">
-              <a14:hiddenEffects xmlns:a14="http://schemas.microsoft.com/office/drawing/2010/main" xmlns="">
+              <a14:hiddenEffects xmlns="" xmlns:a14="http://schemas.microsoft.com/office/drawing/2010/main">
                 <a:effectLst>
                   <a:outerShdw blurRad="63500" dist="35921" dir="2700000" algn="ctr" rotWithShape="0">
                     <a:schemeClr val="bg2"/>
@@ -19305,14 +19642,14 @@
           <a:effectLst/>
           <a:extLst>
             <a:ext uri="{909E8E84-426E-40dd-AFC4-6F175D3DCCD1}">
-              <a14:hiddenFill xmlns:a14="http://schemas.microsoft.com/office/drawing/2010/main" xmlns="">
+              <a14:hiddenFill xmlns="" xmlns:a14="http://schemas.microsoft.com/office/drawing/2010/main">
                 <a:solidFill>
                   <a:schemeClr val="accent1"/>
                 </a:solidFill>
               </a14:hiddenFill>
             </a:ext>
             <a:ext uri="{AF507438-7753-43e0-B8FC-AC1667EBCBE1}">
-              <a14:hiddenEffects xmlns:a14="http://schemas.microsoft.com/office/drawing/2010/main" xmlns="">
+              <a14:hiddenEffects xmlns="" xmlns:a14="http://schemas.microsoft.com/office/drawing/2010/main">
                 <a:effectLst>
                   <a:outerShdw blurRad="63500" dist="35921" dir="2700000" algn="ctr" rotWithShape="0">
                     <a:schemeClr val="bg2"/>
@@ -19875,14 +20212,14 @@
           <a:noFill/>
           <a:extLst>
             <a:ext uri="{909E8E84-426E-40dd-AFC4-6F175D3DCCD1}">
-              <a14:hiddenFill xmlns:a14="http://schemas.microsoft.com/office/drawing/2010/main" xmlns="">
+              <a14:hiddenFill xmlns="" xmlns:a14="http://schemas.microsoft.com/office/drawing/2010/main">
                 <a:solidFill>
                   <a:srgbClr val="FFFFFF"/>
                 </a:solidFill>
               </a14:hiddenFill>
             </a:ext>
             <a:ext uri="{91240B29-F687-4f45-9708-019B960494DF}">
-              <a14:hiddenLine xmlns:a14="http://schemas.microsoft.com/office/drawing/2010/main" xmlns="" w="9525">
+              <a14:hiddenLine xmlns="" xmlns:a14="http://schemas.microsoft.com/office/drawing/2010/main" w="9525">
                 <a:solidFill>
                   <a:srgbClr val="000000"/>
                 </a:solidFill>
@@ -20371,14 +20708,14 @@
           <a:noFill/>
           <a:extLst>
             <a:ext uri="{909E8E84-426E-40dd-AFC4-6F175D3DCCD1}">
-              <a14:hiddenFill xmlns:a14="http://schemas.microsoft.com/office/drawing/2010/main" xmlns="">
+              <a14:hiddenFill xmlns="" xmlns:a14="http://schemas.microsoft.com/office/drawing/2010/main">
                 <a:solidFill>
                   <a:srgbClr val="FFFFFF"/>
                 </a:solidFill>
               </a14:hiddenFill>
             </a:ext>
             <a:ext uri="{91240B29-F687-4f45-9708-019B960494DF}">
-              <a14:hiddenLine xmlns:a14="http://schemas.microsoft.com/office/drawing/2010/main" xmlns="" w="9525">
+              <a14:hiddenLine xmlns="" xmlns:a14="http://schemas.microsoft.com/office/drawing/2010/main" w="9525">
                 <a:solidFill>
                   <a:srgbClr val="000000"/>
                 </a:solidFill>
@@ -20956,14 +21293,14 @@
           <a:noFill/>
           <a:extLst>
             <a:ext uri="{909E8E84-426E-40dd-AFC4-6F175D3DCCD1}">
-              <a14:hiddenFill xmlns:a14="http://schemas.microsoft.com/office/drawing/2010/main" xmlns="">
+              <a14:hiddenFill xmlns="" xmlns:a14="http://schemas.microsoft.com/office/drawing/2010/main">
                 <a:solidFill>
                   <a:srgbClr val="FFFFFF"/>
                 </a:solidFill>
               </a14:hiddenFill>
             </a:ext>
             <a:ext uri="{91240B29-F687-4f45-9708-019B960494DF}">
-              <a14:hiddenLine xmlns:a14="http://schemas.microsoft.com/office/drawing/2010/main" xmlns="" w="9525">
+              <a14:hiddenLine xmlns="" xmlns:a14="http://schemas.microsoft.com/office/drawing/2010/main" w="9525">
                 <a:solidFill>
                   <a:srgbClr val="000000"/>
                 </a:solidFill>
@@ -21156,14 +21493,14 @@
           </a:ln>
           <a:extLst>
             <a:ext uri="{909E8E84-426E-40dd-AFC4-6F175D3DCCD1}">
-              <a14:hiddenFill xmlns:a14="http://schemas.microsoft.com/office/drawing/2010/main" xmlns="">
+              <a14:hiddenFill xmlns="" xmlns:a14="http://schemas.microsoft.com/office/drawing/2010/main">
                 <a:solidFill>
                   <a:srgbClr val="FFFFFF"/>
                 </a:solidFill>
               </a14:hiddenFill>
             </a:ext>
             <a:ext uri="{91240B29-F687-4f45-9708-019B960494DF}">
-              <a14:hiddenLine xmlns:a14="http://schemas.microsoft.com/office/drawing/2010/main" xmlns="" w="9525">
+              <a14:hiddenLine xmlns="" xmlns:a14="http://schemas.microsoft.com/office/drawing/2010/main" w="9525">
                 <a:solidFill>
                   <a:srgbClr val="000000"/>
                 </a:solidFill>
@@ -21493,14 +21830,14 @@
           <a:noFill/>
           <a:extLst>
             <a:ext uri="{909E8E84-426E-40dd-AFC4-6F175D3DCCD1}">
-              <a14:hiddenFill xmlns:a14="http://schemas.microsoft.com/office/drawing/2010/main" xmlns="">
+              <a14:hiddenFill xmlns="" xmlns:a14="http://schemas.microsoft.com/office/drawing/2010/main">
                 <a:solidFill>
                   <a:srgbClr val="FFFFFF"/>
                 </a:solidFill>
               </a14:hiddenFill>
             </a:ext>
             <a:ext uri="{91240B29-F687-4f45-9708-019B960494DF}">
-              <a14:hiddenLine xmlns:a14="http://schemas.microsoft.com/office/drawing/2010/main" xmlns="" w="9525">
+              <a14:hiddenLine xmlns="" xmlns:a14="http://schemas.microsoft.com/office/drawing/2010/main" w="9525">
                 <a:solidFill>
                   <a:srgbClr val="000000"/>
                 </a:solidFill>
@@ -21774,14 +22111,14 @@
           </a:ln>
           <a:extLst>
             <a:ext uri="{909E8E84-426E-40dd-AFC4-6F175D3DCCD1}">
-              <a14:hiddenFill xmlns:a14="http://schemas.microsoft.com/office/drawing/2010/main" xmlns="">
+              <a14:hiddenFill xmlns="" xmlns:a14="http://schemas.microsoft.com/office/drawing/2010/main">
                 <a:solidFill>
                   <a:srgbClr val="FFFFFF"/>
                 </a:solidFill>
               </a14:hiddenFill>
             </a:ext>
             <a:ext uri="{91240B29-F687-4f45-9708-019B960494DF}">
-              <a14:hiddenLine xmlns:a14="http://schemas.microsoft.com/office/drawing/2010/main" xmlns="" w="9525">
+              <a14:hiddenLine xmlns="" xmlns:a14="http://schemas.microsoft.com/office/drawing/2010/main" w="9525">
                 <a:solidFill>
                   <a:srgbClr val="000000"/>
                 </a:solidFill>
@@ -21941,14 +22278,14 @@
           </a:ln>
           <a:extLst>
             <a:ext uri="{909E8E84-426E-40dd-AFC4-6F175D3DCCD1}">
-              <a14:hiddenFill xmlns:a14="http://schemas.microsoft.com/office/drawing/2010/main" xmlns="">
+              <a14:hiddenFill xmlns="" xmlns:a14="http://schemas.microsoft.com/office/drawing/2010/main">
                 <a:solidFill>
                   <a:srgbClr val="FFFFFF"/>
                 </a:solidFill>
               </a14:hiddenFill>
             </a:ext>
             <a:ext uri="{91240B29-F687-4f45-9708-019B960494DF}">
-              <a14:hiddenLine xmlns:a14="http://schemas.microsoft.com/office/drawing/2010/main" xmlns="" w="9525">
+              <a14:hiddenLine xmlns="" xmlns:a14="http://schemas.microsoft.com/office/drawing/2010/main" w="9525">
                 <a:solidFill>
                   <a:srgbClr val="000000"/>
                 </a:solidFill>
@@ -22388,14 +22725,14 @@
           <a:noFill/>
           <a:extLst>
             <a:ext uri="{909E8E84-426E-40dd-AFC4-6F175D3DCCD1}">
-              <a14:hiddenFill xmlns:a14="http://schemas.microsoft.com/office/drawing/2010/main" xmlns="">
+              <a14:hiddenFill xmlns="" xmlns:a14="http://schemas.microsoft.com/office/drawing/2010/main">
                 <a:solidFill>
                   <a:srgbClr val="FFFFFF"/>
                 </a:solidFill>
               </a14:hiddenFill>
             </a:ext>
             <a:ext uri="{91240B29-F687-4f45-9708-019B960494DF}">
-              <a14:hiddenLine xmlns:a14="http://schemas.microsoft.com/office/drawing/2010/main" xmlns="" w="9525">
+              <a14:hiddenLine xmlns="" xmlns:a14="http://schemas.microsoft.com/office/drawing/2010/main" w="9525">
                 <a:solidFill>
                   <a:srgbClr val="000000"/>
                 </a:solidFill>
@@ -22600,14 +22937,14 @@
           </a:ln>
           <a:extLst>
             <a:ext uri="{909E8E84-426E-40dd-AFC4-6F175D3DCCD1}">
-              <a14:hiddenFill xmlns:a14="http://schemas.microsoft.com/office/drawing/2010/main" xmlns="">
+              <a14:hiddenFill xmlns="" xmlns:a14="http://schemas.microsoft.com/office/drawing/2010/main">
                 <a:solidFill>
                   <a:srgbClr val="FFFFFF"/>
                 </a:solidFill>
               </a14:hiddenFill>
             </a:ext>
             <a:ext uri="{91240B29-F687-4f45-9708-019B960494DF}">
-              <a14:hiddenLine xmlns:a14="http://schemas.microsoft.com/office/drawing/2010/main" xmlns="" w="9525">
+              <a14:hiddenLine xmlns="" xmlns:a14="http://schemas.microsoft.com/office/drawing/2010/main" w="9525">
                 <a:solidFill>
                   <a:srgbClr val="000000"/>
                 </a:solidFill>
@@ -22960,14 +23297,14 @@
           <a:noFill/>
           <a:extLst>
             <a:ext uri="{909E8E84-426E-40dd-AFC4-6F175D3DCCD1}">
-              <a14:hiddenFill xmlns:a14="http://schemas.microsoft.com/office/drawing/2010/main" xmlns="">
+              <a14:hiddenFill xmlns="" xmlns:a14="http://schemas.microsoft.com/office/drawing/2010/main">
                 <a:solidFill>
                   <a:srgbClr val="FFFFFF"/>
                 </a:solidFill>
               </a14:hiddenFill>
             </a:ext>
             <a:ext uri="{91240B29-F687-4f45-9708-019B960494DF}">
-              <a14:hiddenLine xmlns:a14="http://schemas.microsoft.com/office/drawing/2010/main" xmlns="" w="9525">
+              <a14:hiddenLine xmlns="" xmlns:a14="http://schemas.microsoft.com/office/drawing/2010/main" w="9525">
                 <a:solidFill>
                   <a:srgbClr val="000000"/>
                 </a:solidFill>
@@ -23415,14 +23752,14 @@
           </a:ln>
           <a:extLst>
             <a:ext uri="{909E8E84-426E-40dd-AFC4-6F175D3DCCD1}">
-              <a14:hiddenFill xmlns:a14="http://schemas.microsoft.com/office/drawing/2010/main" xmlns="">
+              <a14:hiddenFill xmlns="" xmlns:a14="http://schemas.microsoft.com/office/drawing/2010/main">
                 <a:solidFill>
                   <a:srgbClr val="FFFFFF"/>
                 </a:solidFill>
               </a14:hiddenFill>
             </a:ext>
             <a:ext uri="{91240B29-F687-4f45-9708-019B960494DF}">
-              <a14:hiddenLine xmlns:a14="http://schemas.microsoft.com/office/drawing/2010/main" xmlns="" w="9525">
+              <a14:hiddenLine xmlns="" xmlns:a14="http://schemas.microsoft.com/office/drawing/2010/main" w="9525">
                 <a:solidFill>
                   <a:srgbClr val="000000"/>
                 </a:solidFill>
@@ -23899,14 +24236,14 @@
           <a:noFill/>
           <a:extLst>
             <a:ext uri="{909E8E84-426E-40dd-AFC4-6F175D3DCCD1}">
-              <a14:hiddenFill xmlns:a14="http://schemas.microsoft.com/office/drawing/2010/main" xmlns="">
+              <a14:hiddenFill xmlns="" xmlns:a14="http://schemas.microsoft.com/office/drawing/2010/main">
                 <a:solidFill>
                   <a:srgbClr val="FFFFFF"/>
                 </a:solidFill>
               </a14:hiddenFill>
             </a:ext>
             <a:ext uri="{91240B29-F687-4f45-9708-019B960494DF}">
-              <a14:hiddenLine xmlns:a14="http://schemas.microsoft.com/office/drawing/2010/main" xmlns="" w="9525">
+              <a14:hiddenLine xmlns="" xmlns:a14="http://schemas.microsoft.com/office/drawing/2010/main" w="9525">
                 <a:solidFill>
                   <a:srgbClr val="000000"/>
                 </a:solidFill>
@@ -26262,14 +26599,14 @@
           <a:noFill/>
           <a:extLst>
             <a:ext uri="{909E8E84-426E-40dd-AFC4-6F175D3DCCD1}">
-              <a14:hiddenFill xmlns="" xmlns:a14="http://schemas.microsoft.com/office/drawing/2010/main">
+              <a14:hiddenFill xmlns:a14="http://schemas.microsoft.com/office/drawing/2010/main" xmlns="">
                 <a:solidFill>
                   <a:srgbClr val="FFFFFF"/>
                 </a:solidFill>
               </a14:hiddenFill>
             </a:ext>
             <a:ext uri="{91240B29-F687-4f45-9708-019B960494DF}">
-              <a14:hiddenLine xmlns="" xmlns:a14="http://schemas.microsoft.com/office/drawing/2010/main" w="9525">
+              <a14:hiddenLine xmlns:a14="http://schemas.microsoft.com/office/drawing/2010/main" xmlns="" w="9525">
                 <a:solidFill>
                   <a:srgbClr val="000000"/>
                 </a:solidFill>
@@ -34910,14 +35247,14 @@
           <a:noFill/>
           <a:extLst>
             <a:ext uri="{909E8E84-426E-40dd-AFC4-6F175D3DCCD1}">
-              <a14:hiddenFill xmlns:a14="http://schemas.microsoft.com/office/drawing/2010/main" xmlns="">
+              <a14:hiddenFill xmlns="" xmlns:a14="http://schemas.microsoft.com/office/drawing/2010/main">
                 <a:solidFill>
                   <a:srgbClr val="FFFFFF"/>
                 </a:solidFill>
               </a14:hiddenFill>
             </a:ext>
             <a:ext uri="{91240B29-F687-4f45-9708-019B960494DF}">
-              <a14:hiddenLine xmlns:a14="http://schemas.microsoft.com/office/drawing/2010/main" xmlns="" w="9525">
+              <a14:hiddenLine xmlns="" xmlns:a14="http://schemas.microsoft.com/office/drawing/2010/main" w="9525">
                 <a:solidFill>
                   <a:srgbClr val="000000"/>
                 </a:solidFill>
@@ -35738,14 +36075,14 @@
         <p:spPr>
           <a:extLst>
             <a:ext uri="{909E8E84-426E-40dd-AFC4-6F175D3DCCD1}">
-              <a14:hiddenFill xmlns:a14="http://schemas.microsoft.com/office/drawing/2010/main" xmlns="">
+              <a14:hiddenFill xmlns="" xmlns:a14="http://schemas.microsoft.com/office/drawing/2010/main">
                 <a:solidFill>
                   <a:srgbClr val="FFFFFF"/>
                 </a:solidFill>
               </a14:hiddenFill>
             </a:ext>
             <a:ext uri="{91240B29-F687-4f45-9708-019B960494DF}">
-              <a14:hiddenLine xmlns:a14="http://schemas.microsoft.com/office/drawing/2010/main" xmlns="" w="9525">
+              <a14:hiddenLine xmlns="" xmlns:a14="http://schemas.microsoft.com/office/drawing/2010/main" w="9525">
                 <a:solidFill>
                   <a:srgbClr val="000000"/>
                 </a:solidFill>
@@ -35961,14 +36298,14 @@
           <a:noFill/>
           <a:extLst>
             <a:ext uri="{909E8E84-426E-40dd-AFC4-6F175D3DCCD1}">
-              <a14:hiddenFill xmlns="" xmlns:a14="http://schemas.microsoft.com/office/drawing/2010/main">
+              <a14:hiddenFill xmlns:a14="http://schemas.microsoft.com/office/drawing/2010/main" xmlns="">
                 <a:solidFill>
                   <a:srgbClr val="FFFFFF"/>
                 </a:solidFill>
               </a14:hiddenFill>
             </a:ext>
             <a:ext uri="{91240B29-F687-4f45-9708-019B960494DF}">
-              <a14:hiddenLine xmlns="" xmlns:a14="http://schemas.microsoft.com/office/drawing/2010/main" w="9525">
+              <a14:hiddenLine xmlns:a14="http://schemas.microsoft.com/office/drawing/2010/main" xmlns="" w="9525">
                 <a:solidFill>
                   <a:srgbClr val="000000"/>
                 </a:solidFill>
@@ -36806,14 +37143,14 @@
           <a:noFill/>
           <a:extLst>
             <a:ext uri="{909E8E84-426E-40dd-AFC4-6F175D3DCCD1}">
-              <a14:hiddenFill xmlns:a14="http://schemas.microsoft.com/office/drawing/2010/main" xmlns="">
+              <a14:hiddenFill xmlns="" xmlns:a14="http://schemas.microsoft.com/office/drawing/2010/main">
                 <a:solidFill>
                   <a:srgbClr val="FFFFFF"/>
                 </a:solidFill>
               </a14:hiddenFill>
             </a:ext>
             <a:ext uri="{91240B29-F687-4f45-9708-019B960494DF}">
-              <a14:hiddenLine xmlns:a14="http://schemas.microsoft.com/office/drawing/2010/main" xmlns="" w="9525">
+              <a14:hiddenLine xmlns="" xmlns:a14="http://schemas.microsoft.com/office/drawing/2010/main" w="9525">
                 <a:solidFill>
                   <a:srgbClr val="000000"/>
                 </a:solidFill>
@@ -37758,14 +38095,14 @@
           <a:noFill/>
           <a:extLst>
             <a:ext uri="{909E8E84-426E-40dd-AFC4-6F175D3DCCD1}">
-              <a14:hiddenFill xmlns="" xmlns:a14="http://schemas.microsoft.com/office/drawing/2010/main">
+              <a14:hiddenFill xmlns:a14="http://schemas.microsoft.com/office/drawing/2010/main" xmlns="">
                 <a:solidFill>
                   <a:srgbClr val="FFFFFF"/>
                 </a:solidFill>
               </a14:hiddenFill>
             </a:ext>
             <a:ext uri="{91240B29-F687-4f45-9708-019B960494DF}">
-              <a14:hiddenLine xmlns="" xmlns:a14="http://schemas.microsoft.com/office/drawing/2010/main" w="9525">
+              <a14:hiddenLine xmlns:a14="http://schemas.microsoft.com/office/drawing/2010/main" xmlns="" w="9525">
                 <a:solidFill>
                   <a:srgbClr val="000000"/>
                 </a:solidFill>
@@ -38938,14 +39275,14 @@
           <a:noFill/>
           <a:extLst>
             <a:ext uri="{909E8E84-426E-40dd-AFC4-6F175D3DCCD1}">
-              <a14:hiddenFill xmlns:a14="http://schemas.microsoft.com/office/drawing/2010/main" xmlns="">
+              <a14:hiddenFill xmlns="" xmlns:a14="http://schemas.microsoft.com/office/drawing/2010/main">
                 <a:solidFill>
                   <a:srgbClr val="FFFFFF"/>
                 </a:solidFill>
               </a14:hiddenFill>
             </a:ext>
             <a:ext uri="{91240B29-F687-4f45-9708-019B960494DF}">
-              <a14:hiddenLine xmlns:a14="http://schemas.microsoft.com/office/drawing/2010/main" xmlns="" w="9525">
+              <a14:hiddenLine xmlns="" xmlns:a14="http://schemas.microsoft.com/office/drawing/2010/main" w="9525">
                 <a:solidFill>
                   <a:srgbClr val="000000"/>
                 </a:solidFill>
@@ -39090,8 +39427,8 @@
         </p:nvSpPr>
         <p:spPr>
           <a:xfrm>
-            <a:off x="616527" y="2602512"/>
-            <a:ext cx="8840882" cy="2677656"/>
+            <a:off x="616526" y="2602512"/>
+            <a:ext cx="10433391" cy="2246769"/>
           </a:xfrm>
           <a:prstGeom prst="rect">
             <a:avLst/>
@@ -39099,7 +39436,7 @@
           <a:noFill/>
         </p:spPr>
         <p:txBody>
-          <a:bodyPr wrap="none" rtlCol="0">
+          <a:bodyPr wrap="square" rtlCol="0">
             <a:spAutoFit/>
           </a:bodyPr>
           <a:lstStyle/>
@@ -39110,13 +39447,7 @@
             </a:pPr>
             <a:r>
               <a:rPr lang="en-US" sz="2800" dirty="0"/>
-              <a:t>In this course, we use recursion a lot, starting  </a:t>
-            </a:r>
-          </a:p>
-          <a:p>
-            <a:r>
-              <a:rPr lang="en-US" sz="2800" dirty="0"/>
-              <a:t>with lists</a:t>
+              <a:t>In this course, we use recursion a lot, starting with lists</a:t>
             </a:r>
           </a:p>
           <a:p>
@@ -39133,13 +39464,7 @@
             </a:pPr>
             <a:r>
               <a:rPr lang="en-US" sz="2800" dirty="0"/>
-              <a:t>But first… try to think of something you do in your </a:t>
-            </a:r>
-          </a:p>
-          <a:p>
-            <a:r>
-              <a:rPr lang="en-US" sz="2800" dirty="0"/>
-              <a:t>everyday life that you could describe recursively.</a:t>
+              <a:t>But first… try to think of something you do in your everyday life that you could describe recursively.</a:t>
             </a:r>
           </a:p>
           <a:p>
@@ -39269,15 +39594,33 @@
                                   </p:childTnLst>
                                 </p:cTn>
                               </p:par>
+                            </p:childTnLst>
+                          </p:cTn>
+                        </p:par>
+                      </p:childTnLst>
+                    </p:cTn>
+                  </p:par>
+                  <p:par>
+                    <p:cTn id="9" fill="hold">
+                      <p:stCondLst>
+                        <p:cond delay="indefinite"/>
+                      </p:stCondLst>
+                      <p:childTnLst>
+                        <p:par>
+                          <p:cTn id="10" fill="hold">
+                            <p:stCondLst>
+                              <p:cond delay="0"/>
+                            </p:stCondLst>
+                            <p:childTnLst>
                               <p:par>
-                                <p:cTn id="9" presetID="2" presetClass="entr" presetSubtype="4" fill="hold" nodeType="withEffect">
+                                <p:cTn id="11" presetID="2" presetClass="entr" presetSubtype="4" fill="hold" nodeType="clickEffect">
                                   <p:stCondLst>
                                     <p:cond delay="0"/>
                                   </p:stCondLst>
                                   <p:childTnLst>
                                     <p:set>
                                       <p:cBhvr>
-                                        <p:cTn id="10" dur="1" fill="hold">
+                                        <p:cTn id="12" dur="1" fill="hold">
                                           <p:stCondLst>
                                             <p:cond delay="0"/>
                                           </p:stCondLst>
@@ -39285,7 +39628,7 @@
                                         <p:tgtEl>
                                           <p:spTgt spid="4">
                                             <p:txEl>
-                                              <p:pRg st="1" end="1"/>
+                                              <p:pRg st="2" end="2"/>
                                             </p:txEl>
                                           </p:spTgt>
                                         </p:tgtEl>
@@ -39299,11 +39642,11 @@
                                     </p:set>
                                     <p:anim calcmode="lin" valueType="num">
                                       <p:cBhvr additive="base">
-                                        <p:cTn id="11" dur="500" fill="hold"/>
+                                        <p:cTn id="13" dur="500" fill="hold"/>
                                         <p:tgtEl>
                                           <p:spTgt spid="4">
                                             <p:txEl>
-                                              <p:pRg st="1" end="1"/>
+                                              <p:pRg st="2" end="2"/>
                                             </p:txEl>
                                           </p:spTgt>
                                         </p:tgtEl>
@@ -39326,199 +39669,11 @@
                                     </p:anim>
                                     <p:anim calcmode="lin" valueType="num">
                                       <p:cBhvr additive="base">
-                                        <p:cTn id="12" dur="500" fill="hold"/>
+                                        <p:cTn id="14" dur="500" fill="hold"/>
                                         <p:tgtEl>
                                           <p:spTgt spid="4">
                                             <p:txEl>
-                                              <p:pRg st="1" end="1"/>
-                                            </p:txEl>
-                                          </p:spTgt>
-                                        </p:tgtEl>
-                                        <p:attrNameLst>
-                                          <p:attrName>ppt_y</p:attrName>
-                                        </p:attrNameLst>
-                                      </p:cBhvr>
-                                      <p:tavLst>
-                                        <p:tav tm="0">
-                                          <p:val>
-                                            <p:strVal val="1+#ppt_h/2"/>
-                                          </p:val>
-                                        </p:tav>
-                                        <p:tav tm="100000">
-                                          <p:val>
-                                            <p:strVal val="#ppt_y"/>
-                                          </p:val>
-                                        </p:tav>
-                                      </p:tavLst>
-                                    </p:anim>
-                                  </p:childTnLst>
-                                </p:cTn>
-                              </p:par>
-                            </p:childTnLst>
-                          </p:cTn>
-                        </p:par>
-                      </p:childTnLst>
-                    </p:cTn>
-                  </p:par>
-                  <p:par>
-                    <p:cTn id="13" fill="hold">
-                      <p:stCondLst>
-                        <p:cond delay="indefinite"/>
-                      </p:stCondLst>
-                      <p:childTnLst>
-                        <p:par>
-                          <p:cTn id="14" fill="hold">
-                            <p:stCondLst>
-                              <p:cond delay="0"/>
-                            </p:stCondLst>
-                            <p:childTnLst>
-                              <p:par>
-                                <p:cTn id="15" presetID="2" presetClass="entr" presetSubtype="4" fill="hold" nodeType="clickEffect">
-                                  <p:stCondLst>
-                                    <p:cond delay="0"/>
-                                  </p:stCondLst>
-                                  <p:childTnLst>
-                                    <p:set>
-                                      <p:cBhvr>
-                                        <p:cTn id="16" dur="1" fill="hold">
-                                          <p:stCondLst>
-                                            <p:cond delay="0"/>
-                                          </p:stCondLst>
-                                        </p:cTn>
-                                        <p:tgtEl>
-                                          <p:spTgt spid="4">
-                                            <p:txEl>
-                                              <p:pRg st="3" end="3"/>
-                                            </p:txEl>
-                                          </p:spTgt>
-                                        </p:tgtEl>
-                                        <p:attrNameLst>
-                                          <p:attrName>style.visibility</p:attrName>
-                                        </p:attrNameLst>
-                                      </p:cBhvr>
-                                      <p:to>
-                                        <p:strVal val="visible"/>
-                                      </p:to>
-                                    </p:set>
-                                    <p:anim calcmode="lin" valueType="num">
-                                      <p:cBhvr additive="base">
-                                        <p:cTn id="17" dur="500" fill="hold"/>
-                                        <p:tgtEl>
-                                          <p:spTgt spid="4">
-                                            <p:txEl>
-                                              <p:pRg st="3" end="3"/>
-                                            </p:txEl>
-                                          </p:spTgt>
-                                        </p:tgtEl>
-                                        <p:attrNameLst>
-                                          <p:attrName>ppt_x</p:attrName>
-                                        </p:attrNameLst>
-                                      </p:cBhvr>
-                                      <p:tavLst>
-                                        <p:tav tm="0">
-                                          <p:val>
-                                            <p:strVal val="#ppt_x"/>
-                                          </p:val>
-                                        </p:tav>
-                                        <p:tav tm="100000">
-                                          <p:val>
-                                            <p:strVal val="#ppt_x"/>
-                                          </p:val>
-                                        </p:tav>
-                                      </p:tavLst>
-                                    </p:anim>
-                                    <p:anim calcmode="lin" valueType="num">
-                                      <p:cBhvr additive="base">
-                                        <p:cTn id="18" dur="500" fill="hold"/>
-                                        <p:tgtEl>
-                                          <p:spTgt spid="4">
-                                            <p:txEl>
-                                              <p:pRg st="3" end="3"/>
-                                            </p:txEl>
-                                          </p:spTgt>
-                                        </p:tgtEl>
-                                        <p:attrNameLst>
-                                          <p:attrName>ppt_y</p:attrName>
-                                        </p:attrNameLst>
-                                      </p:cBhvr>
-                                      <p:tavLst>
-                                        <p:tav tm="0">
-                                          <p:val>
-                                            <p:strVal val="1+#ppt_h/2"/>
-                                          </p:val>
-                                        </p:tav>
-                                        <p:tav tm="100000">
-                                          <p:val>
-                                            <p:strVal val="#ppt_y"/>
-                                          </p:val>
-                                        </p:tav>
-                                      </p:tavLst>
-                                    </p:anim>
-                                  </p:childTnLst>
-                                </p:cTn>
-                              </p:par>
-                              <p:par>
-                                <p:cTn id="19" presetID="2" presetClass="entr" presetSubtype="4" fill="hold" nodeType="withEffect">
-                                  <p:stCondLst>
-                                    <p:cond delay="0"/>
-                                  </p:stCondLst>
-                                  <p:childTnLst>
-                                    <p:set>
-                                      <p:cBhvr>
-                                        <p:cTn id="20" dur="1" fill="hold">
-                                          <p:stCondLst>
-                                            <p:cond delay="0"/>
-                                          </p:stCondLst>
-                                        </p:cTn>
-                                        <p:tgtEl>
-                                          <p:spTgt spid="4">
-                                            <p:txEl>
-                                              <p:pRg st="4" end="4"/>
-                                            </p:txEl>
-                                          </p:spTgt>
-                                        </p:tgtEl>
-                                        <p:attrNameLst>
-                                          <p:attrName>style.visibility</p:attrName>
-                                        </p:attrNameLst>
-                                      </p:cBhvr>
-                                      <p:to>
-                                        <p:strVal val="visible"/>
-                                      </p:to>
-                                    </p:set>
-                                    <p:anim calcmode="lin" valueType="num">
-                                      <p:cBhvr additive="base">
-                                        <p:cTn id="21" dur="500" fill="hold"/>
-                                        <p:tgtEl>
-                                          <p:spTgt spid="4">
-                                            <p:txEl>
-                                              <p:pRg st="4" end="4"/>
-                                            </p:txEl>
-                                          </p:spTgt>
-                                        </p:tgtEl>
-                                        <p:attrNameLst>
-                                          <p:attrName>ppt_x</p:attrName>
-                                        </p:attrNameLst>
-                                      </p:cBhvr>
-                                      <p:tavLst>
-                                        <p:tav tm="0">
-                                          <p:val>
-                                            <p:strVal val="#ppt_x"/>
-                                          </p:val>
-                                        </p:tav>
-                                        <p:tav tm="100000">
-                                          <p:val>
-                                            <p:strVal val="#ppt_x"/>
-                                          </p:val>
-                                        </p:tav>
-                                      </p:tavLst>
-                                    </p:anim>
-                                    <p:anim calcmode="lin" valueType="num">
-                                      <p:cBhvr additive="base">
-                                        <p:cTn id="22" dur="500" fill="hold"/>
-                                        <p:tgtEl>
-                                          <p:spTgt spid="4">
-                                            <p:txEl>
-                                              <p:pRg st="4" end="4"/>
+                                              <p:pRg st="2" end="2"/>
                                             </p:txEl>
                                           </p:spTgt>
                                         </p:tgtEl>
@@ -39629,14 +39784,14 @@
           <a:noFill/>
           <a:extLst>
             <a:ext uri="{909E8E84-426E-40dd-AFC4-6F175D3DCCD1}">
-              <a14:hiddenFill xmlns="" xmlns:a14="http://schemas.microsoft.com/office/drawing/2010/main">
+              <a14:hiddenFill xmlns:a14="http://schemas.microsoft.com/office/drawing/2010/main" xmlns="">
                 <a:solidFill>
                   <a:srgbClr val="FFFFFF"/>
                 </a:solidFill>
               </a14:hiddenFill>
             </a:ext>
             <a:ext uri="{91240B29-F687-4f45-9708-019B960494DF}">
-              <a14:hiddenLine xmlns="" xmlns:a14="http://schemas.microsoft.com/office/drawing/2010/main" w="9525">
+              <a14:hiddenLine xmlns:a14="http://schemas.microsoft.com/office/drawing/2010/main" xmlns="" w="9525">
                 <a:solidFill>
                   <a:srgbClr val="000000"/>
                 </a:solidFill>

</xml_diff>